<commit_message>
docs+chore: ADRs, manuais, portfolio e templates de ambiente
- docs: ADR-0005 (gestão de usuários/controle de acesso), ADR-0006 (build do app
  por entidade), manual do sistema, manuais de atendimento/canais e campanhas,
  banco de dados.
- portfolio: apresentação/portfólio e assets atualizados (propostas por cliente
  ficam fora — gitignored).
- .env.example / .env.prod.example: novas chaves (IA web search, WhatsApp Meta,
  campanhas, etc.) — apenas placeholders.

Co-Authored-By: Claude Opus 4.8 (1M context) <noreply@anthropic.com>
</commit_message>
<xml_diff>
--- a/portfolio/Apresentacao-Portal-Prefeitura.pptx
+++ b/portfolio/Apresentacao-Portal-Prefeitura.pptx
@@ -3378,7 +3378,7 @@
                 </a:solidFill>
                 <a:latin typeface="Calibri"/>
               </a:rPr>
-              <a:t>Selo Diamante (PNTP) · Multi-tenant · Gov.br · LGPD</a:t>
+              <a:t>Selo Diamante (PNTP) · Multi-tenant · Gov.br · LGPD · IA em Produção</a:t>
             </a:r>
           </a:p>
           <a:p>
@@ -3663,11 +3663,11 @@
                 <a:spcPts val="0"/>
               </a:spcBef>
               <a:spcAft>
-                <a:spcPts val="1100"/>
-              </a:spcAft>
-            </a:pPr>
-            <a:r>
-              <a:rPr sz="1600" b="1">
+                <a:spcPts val="1000"/>
+              </a:spcAft>
+            </a:pPr>
+            <a:r>
+              <a:rPr sz="1500" b="1">
                 <a:solidFill>
                   <a:srgbClr val="1351B4"/>
                 </a:solidFill>
@@ -3676,13 +3676,13 @@
               <a:t>▸  </a:t>
             </a:r>
             <a:r>
-              <a:rPr sz="1600">
+              <a:rPr sz="1500">
                 <a:solidFill>
                   <a:srgbClr val="333942"/>
                 </a:solidFill>
                 <a:latin typeface="Calibri"/>
               </a:rPr>
-              <a:t>Isolamento por RLS: cada consulta é restrita ao município.</a:t>
+              <a:t>Isolamento por RLS: cada consulta é restrita ao município — impossível cruzar dados entre prefeituras.</a:t>
             </a:r>
           </a:p>
           <a:p>
@@ -3691,11 +3691,11 @@
                 <a:spcPts val="0"/>
               </a:spcBef>
               <a:spcAft>
-                <a:spcPts val="1100"/>
-              </a:spcAft>
-            </a:pPr>
-            <a:r>
-              <a:rPr sz="1600" b="1">
+                <a:spcPts val="1000"/>
+              </a:spcAft>
+            </a:pPr>
+            <a:r>
+              <a:rPr sz="1500" b="1">
                 <a:solidFill>
                   <a:srgbClr val="1351B4"/>
                 </a:solidFill>
@@ -3704,13 +3704,13 @@
               <a:t>▸  </a:t>
             </a:r>
             <a:r>
-              <a:rPr sz="1600">
+              <a:rPr sz="1500">
                 <a:solidFill>
                   <a:srgbClr val="333942"/>
                 </a:solidFill>
                 <a:latin typeface="Calibri"/>
               </a:rPr>
-              <a:t>RBAC: papéis (administrador, gestor, ouvidor, servidor, cidadão) controlam cada ação.</a:t>
+              <a:t>Sigilo jurídico da ouvidoria: RBAC + RLS por papel — denúncias invisíveis até para o administrador da prefeitura.</a:t>
             </a:r>
           </a:p>
           <a:p>
@@ -3719,11 +3719,11 @@
                 <a:spcPts val="0"/>
               </a:spcBef>
               <a:spcAft>
-                <a:spcPts val="1100"/>
-              </a:spcAft>
-            </a:pPr>
-            <a:r>
-              <a:rPr sz="1600" b="1">
+                <a:spcPts val="1000"/>
+              </a:spcAft>
+            </a:pPr>
+            <a:r>
+              <a:rPr sz="1500" b="1">
                 <a:solidFill>
                   <a:srgbClr val="1351B4"/>
                 </a:solidFill>
@@ -3732,13 +3732,13 @@
               <a:t>▸  </a:t>
             </a:r>
             <a:r>
-              <a:rPr sz="1600">
+              <a:rPr sz="1500">
                 <a:solidFill>
                   <a:srgbClr val="333942"/>
                 </a:solidFill>
                 <a:latin typeface="Calibri"/>
               </a:rPr>
-              <a:t>LGPD por projeto: base legal por finalidade e logs de acesso a dados pessoais.</a:t>
+              <a:t>Autocadastro de usuário + solicitação de elevação por cargo; ouvidor exige aprovação da operadora e assina termo de sigilo.</a:t>
             </a:r>
           </a:p>
           <a:p>
@@ -3747,11 +3747,11 @@
                 <a:spcPts val="0"/>
               </a:spcBef>
               <a:spcAft>
-                <a:spcPts val="1100"/>
-              </a:spcAft>
-            </a:pPr>
-            <a:r>
-              <a:rPr sz="1600" b="1">
+                <a:spcPts val="1000"/>
+              </a:spcAft>
+            </a:pPr>
+            <a:r>
+              <a:rPr sz="1500" b="1">
                 <a:solidFill>
                   <a:srgbClr val="1351B4"/>
                 </a:solidFill>
@@ -3760,13 +3760,13 @@
               <a:t>▸  </a:t>
             </a:r>
             <a:r>
-              <a:rPr sz="1600">
+              <a:rPr sz="1500">
                 <a:solidFill>
                   <a:srgbClr val="333942"/>
                 </a:solidFill>
                 <a:latin typeface="Calibri"/>
               </a:rPr>
-              <a:t>Auditoria de toda ação sensível e de falhas de processamento.</a:t>
+              <a:t>Escopo por secretaria: servidor só gerencia o conteúdo da sua área.</a:t>
             </a:r>
           </a:p>
           <a:p>
@@ -3775,11 +3775,11 @@
                 <a:spcPts val="0"/>
               </a:spcBef>
               <a:spcAft>
-                <a:spcPts val="1100"/>
-              </a:spcAft>
-            </a:pPr>
-            <a:r>
-              <a:rPr sz="1600" b="1">
+                <a:spcPts val="1000"/>
+              </a:spcAft>
+            </a:pPr>
+            <a:r>
+              <a:rPr sz="1500" b="1">
                 <a:solidFill>
                   <a:srgbClr val="1351B4"/>
                 </a:solidFill>
@@ -3788,13 +3788,13 @@
               <a:t>▸  </a:t>
             </a:r>
             <a:r>
-              <a:rPr sz="1600">
+              <a:rPr sz="1500">
                 <a:solidFill>
                   <a:srgbClr val="333942"/>
                 </a:solidFill>
                 <a:latin typeface="Calibri"/>
               </a:rPr>
-              <a:t>Borda protegida: nada exposto direto à internet — proxy + WAF + TLS.</a:t>
+              <a:t>Cloudflare Turnstile: proteção anti-robô em logins e formulários sem CAPTCHA incômodo.</a:t>
             </a:r>
           </a:p>
           <a:p>
@@ -3803,11 +3803,11 @@
                 <a:spcPts val="0"/>
               </a:spcBef>
               <a:spcAft>
-                <a:spcPts val="1100"/>
-              </a:spcAft>
-            </a:pPr>
-            <a:r>
-              <a:rPr sz="1600" b="1">
+                <a:spcPts val="1000"/>
+              </a:spcAft>
+            </a:pPr>
+            <a:r>
+              <a:rPr sz="1500" b="1">
                 <a:solidFill>
                   <a:srgbClr val="1351B4"/>
                 </a:solidFill>
@@ -3816,13 +3816,41 @@
               <a:t>▸  </a:t>
             </a:r>
             <a:r>
-              <a:rPr sz="1600">
+              <a:rPr sz="1500">
                 <a:solidFill>
                   <a:srgbClr val="333942"/>
                 </a:solidFill>
                 <a:latin typeface="Calibri"/>
               </a:rPr>
-              <a:t>Login gov.br: identidade forte sem o município guardar senha.</a:t>
+              <a:t>LGPD por projeto: base legal por finalidade, logs de acesso, auditoria completa.</a:t>
+            </a:r>
+          </a:p>
+          <a:p>
+            <a:pPr>
+              <a:spcBef>
+                <a:spcPts val="0"/>
+              </a:spcBef>
+              <a:spcAft>
+                <a:spcPts val="1000"/>
+              </a:spcAft>
+            </a:pPr>
+            <a:r>
+              <a:rPr sz="1500" b="1">
+                <a:solidFill>
+                  <a:srgbClr val="1351B4"/>
+                </a:solidFill>
+                <a:latin typeface="Calibri"/>
+              </a:rPr>
+              <a:t>▸  </a:t>
+            </a:r>
+            <a:r>
+              <a:rPr sz="1500">
+                <a:solidFill>
+                  <a:srgbClr val="333942"/>
+                </a:solidFill>
+                <a:latin typeface="Calibri"/>
+              </a:rPr>
+              <a:t>Borda protegida: Cloudflare Zero Trust + WAF + TLS. Login gov.br para cidadãos.</a:t>
             </a:r>
           </a:p>
         </p:txBody>
@@ -4544,7 +4572,7 @@
                 </a:solidFill>
                 <a:latin typeface="Calibri"/>
               </a:rPr>
-              <a:t>Chatbot que responde da base oficial da prefeitura (RAG).</a:t>
+              <a:t>Chatbot com busca híbrida (palavra + significado) + OCR de PDFs antigos.</a:t>
             </a:r>
           </a:p>
           <a:p>
@@ -4572,7 +4600,7 @@
                 </a:solidFill>
                 <a:latin typeface="Calibri"/>
               </a:rPr>
-              <a:t>Triagem automática de manifestações, com revisão humana.</a:t>
+              <a:t>Base treinável pelo gestor: artigos livres viram conhecimento da IA.</a:t>
             </a:r>
           </a:p>
           <a:p>
@@ -4600,7 +4628,7 @@
                 </a:solidFill>
                 <a:latin typeface="Calibri"/>
               </a:rPr>
-              <a:t>Busca unificada com OCR de PDFs digitalizados.</a:t>
+              <a:t>Bot agêntico: executa ações por linguagem natural (abre protocolo, consulta status).</a:t>
             </a:r>
           </a:p>
           <a:p>
@@ -4628,7 +4656,7 @@
                 </a:solidFill>
                 <a:latin typeface="Calibri"/>
               </a:rPr>
-              <a:t>IA fiscal sobre os dados da transparência.</a:t>
+              <a:t>Moderação automática de comentários e IA fiscal na transparência.</a:t>
             </a:r>
           </a:p>
         </p:txBody>
@@ -5734,7 +5762,7 @@
                 </a:solidFill>
                 <a:latin typeface="Calibri"/>
               </a:rPr>
-              <a:t>IMPLANTAÇÃO</a:t>
+              <a:t>IMPLANTAÇÃO &amp; ROADMAP</a:t>
             </a:r>
           </a:p>
         </p:txBody>
@@ -5808,11 +5836,11 @@
                 <a:spcPts val="0"/>
               </a:spcBef>
               <a:spcAft>
-                <a:spcPts val="1000"/>
-              </a:spcAft>
-            </a:pPr>
-            <a:r>
-              <a:rPr sz="1600" b="1">
+                <a:spcPts val="900"/>
+              </a:spcAft>
+            </a:pPr>
+            <a:r>
+              <a:rPr sz="1500" b="1">
                 <a:solidFill>
                   <a:srgbClr val="1351B4"/>
                 </a:solidFill>
@@ -5821,7 +5849,7 @@
               <a:t>▸  </a:t>
             </a:r>
             <a:r>
-              <a:rPr sz="1600">
+              <a:rPr sz="1500">
                 <a:solidFill>
                   <a:srgbClr val="333942"/>
                 </a:solidFill>
@@ -5836,11 +5864,11 @@
                 <a:spcPts val="0"/>
               </a:spcBef>
               <a:spcAft>
-                <a:spcPts val="1000"/>
-              </a:spcAft>
-            </a:pPr>
-            <a:r>
-              <a:rPr sz="1600" b="1">
+                <a:spcPts val="900"/>
+              </a:spcAft>
+            </a:pPr>
+            <a:r>
+              <a:rPr sz="1500" b="1">
                 <a:solidFill>
                   <a:srgbClr val="1351B4"/>
                 </a:solidFill>
@@ -5849,7 +5877,7 @@
               <a:t>▸  </a:t>
             </a:r>
             <a:r>
-              <a:rPr sz="1600">
+              <a:rPr sz="1500">
                 <a:solidFill>
                   <a:srgbClr val="333942"/>
                 </a:solidFill>
@@ -5864,11 +5892,11 @@
                 <a:spcPts val="0"/>
               </a:spcBef>
               <a:spcAft>
-                <a:spcPts val="1000"/>
-              </a:spcAft>
-            </a:pPr>
-            <a:r>
-              <a:rPr sz="1600" b="1">
+                <a:spcPts val="900"/>
+              </a:spcAft>
+            </a:pPr>
+            <a:r>
+              <a:rPr sz="1500" b="1">
                 <a:solidFill>
                   <a:srgbClr val="1351B4"/>
                 </a:solidFill>
@@ -5877,7 +5905,7 @@
               <a:t>▸  </a:t>
             </a:r>
             <a:r>
-              <a:rPr sz="1600">
+              <a:rPr sz="1500">
                 <a:solidFill>
                   <a:srgbClr val="333942"/>
                 </a:solidFill>
@@ -5892,11 +5920,11 @@
                 <a:spcPts val="0"/>
               </a:spcBef>
               <a:spcAft>
-                <a:spcPts val="1000"/>
-              </a:spcAft>
-            </a:pPr>
-            <a:r>
-              <a:rPr sz="1600" b="1">
+                <a:spcPts val="900"/>
+              </a:spcAft>
+            </a:pPr>
+            <a:r>
+              <a:rPr sz="1500" b="1">
                 <a:solidFill>
                   <a:srgbClr val="1351B4"/>
                 </a:solidFill>
@@ -5905,13 +5933,41 @@
               <a:t>▸  </a:t>
             </a:r>
             <a:r>
-              <a:rPr sz="1600">
+              <a:rPr sz="1500">
                 <a:solidFill>
                   <a:srgbClr val="333942"/>
                 </a:solidFill>
                 <a:latin typeface="Calibri"/>
               </a:rPr>
               <a:t>Treinamento das equipes e suporte continuado.</a:t>
+            </a:r>
+          </a:p>
+          <a:p>
+            <a:pPr>
+              <a:spcBef>
+                <a:spcPts val="0"/>
+              </a:spcBef>
+              <a:spcAft>
+                <a:spcPts val="900"/>
+              </a:spcAft>
+            </a:pPr>
+            <a:r>
+              <a:rPr sz="1500" b="1">
+                <a:solidFill>
+                  <a:srgbClr val="1351B4"/>
+                </a:solidFill>
+                <a:latin typeface="Calibri"/>
+              </a:rPr>
+              <a:t>▸  </a:t>
+            </a:r>
+            <a:r>
+              <a:rPr sz="1500">
+                <a:solidFill>
+                  <a:srgbClr val="333942"/>
+                </a:solidFill>
+                <a:latin typeface="Calibri"/>
+              </a:rPr>
+              <a:t>Fases concluídas: Fundação · Transparência · Serviços+CMS · Diário Oficial · IA.</a:t>
             </a:r>
           </a:p>
         </p:txBody>
@@ -9633,7 +9689,7 @@
                 </a:solidFill>
                 <a:latin typeface="Calibri"/>
               </a:rPr>
-              <a:t>Ouvidoria/e-SIC · Atendimento omnichannel · Enquetes · Formulários · App do Cidadão</a:t>
+              <a:t>Ouvidoria/e-SIC · Bot agêntico 24h · WhatsApp · Enquetes · Formulários · Moderação IA · App do Cidadão</a:t>
             </a:r>
           </a:p>
         </p:txBody>
@@ -10149,7 +10205,7 @@
                 </a:solidFill>
                 <a:latin typeface="Calibri"/>
               </a:rPr>
-              <a:t>Gerenciador multi-tenant · Usuários/Grupos/Sessões · Chat interno · Configurações</a:t>
+              <a:t>Gerenciador multi-tenant · Usuários/Grupos/Sessões · Escopo por secretaria · Chat interno</a:t>
             </a:r>
           </a:p>
         </p:txBody>
@@ -10321,7 +10377,7 @@
                 </a:solidFill>
                 <a:latin typeface="Calibri"/>
               </a:rPr>
-              <a:t>Chatbot RAG · Triagem de manifestações · Busca com OCR · IA fiscal</a:t>
+              <a:t>Chatbot híbrido RAG+semântico · Base treinável pelo gestor · OCR PDFs · Assistente de servidores · IA fiscal</a:t>
             </a:r>
           </a:p>
         </p:txBody>
@@ -10493,7 +10549,7 @@
                 </a:solidFill>
                 <a:latin typeface="Calibri"/>
               </a:rPr>
-              <a:t>LGPD self-service · RLS · RBAC · WCAG/VLibras · Login gov.br</a:t>
+              <a:t>LGPD self-service · Sigilo ouvidoria (RBAC+RLS) · Turnstile anti-robô · WCAG/VLibras · Login gov.br</a:t>
             </a:r>
           </a:p>
         </p:txBody>

</xml_diff>